<commit_message>
chore(preview): indice_DAX40 outputs regeneres
</commit_message>
<xml_diff>
--- a/preview/indice_DAX40/indice_DAX40.pptx
+++ b/preview/indice_DAX40/indice_DAX40.pptx
@@ -8215,7 +8215,7 @@
         <p:spPr>
           <a:xfrm>
             <a:off x="468000" y="1620000"/>
-            <a:ext cx="720000" cy="198000"/>
+            <a:ext cx="684000" cy="198000"/>
           </a:xfrm>
           <a:prstGeom prst="rect">
             <a:avLst/>
@@ -8248,8 +8248,8 @@
         </p:nvSpPr>
         <p:spPr>
           <a:xfrm>
-            <a:off x="1188000" y="1620000"/>
-            <a:ext cx="468000" cy="198000"/>
+            <a:off x="1152000" y="1620000"/>
+            <a:ext cx="540000" cy="198000"/>
           </a:xfrm>
           <a:prstGeom prst="rect">
             <a:avLst/>
@@ -8282,7 +8282,7 @@
         </p:nvSpPr>
         <p:spPr>
           <a:xfrm>
-            <a:off x="1655999" y="1620000"/>
+            <a:off x="1692000" y="1620000"/>
             <a:ext cx="540000" cy="198000"/>
           </a:xfrm>
           <a:prstGeom prst="rect">
@@ -8316,7 +8316,7 @@
         </p:nvSpPr>
         <p:spPr>
           <a:xfrm>
-            <a:off x="2196000" y="1620000"/>
+            <a:off x="2232000" y="1620000"/>
             <a:ext cx="540000" cy="198000"/>
           </a:xfrm>
           <a:prstGeom prst="rect">
@@ -8394,7 +8394,7 @@
         <p:spPr>
           <a:xfrm>
             <a:off x="468000" y="1915200"/>
-            <a:ext cx="720000" cy="198000"/>
+            <a:ext cx="684000" cy="198000"/>
           </a:xfrm>
           <a:prstGeom prst="rect">
             <a:avLst/>
@@ -8427,8 +8427,8 @@
         </p:nvSpPr>
         <p:spPr>
           <a:xfrm>
-            <a:off x="1188000" y="1915200"/>
-            <a:ext cx="468000" cy="198000"/>
+            <a:off x="1152000" y="1915200"/>
+            <a:ext cx="540000" cy="198000"/>
           </a:xfrm>
           <a:prstGeom prst="rect">
             <a:avLst/>
@@ -8461,7 +8461,7 @@
         </p:nvSpPr>
         <p:spPr>
           <a:xfrm>
-            <a:off x="1655999" y="1915200"/>
+            <a:off x="1692000" y="1915200"/>
             <a:ext cx="540000" cy="198000"/>
           </a:xfrm>
           <a:prstGeom prst="rect">
@@ -8495,7 +8495,7 @@
         </p:nvSpPr>
         <p:spPr>
           <a:xfrm>
-            <a:off x="2196000" y="1915200"/>
+            <a:off x="2232000" y="1915200"/>
             <a:ext cx="540000" cy="198000"/>
           </a:xfrm>
           <a:prstGeom prst="rect">
@@ -8573,7 +8573,7 @@
         <p:spPr>
           <a:xfrm>
             <a:off x="468000" y="2210400"/>
-            <a:ext cx="720000" cy="198000"/>
+            <a:ext cx="684000" cy="198000"/>
           </a:xfrm>
           <a:prstGeom prst="rect">
             <a:avLst/>
@@ -8606,8 +8606,8 @@
         </p:nvSpPr>
         <p:spPr>
           <a:xfrm>
-            <a:off x="1188000" y="2210400"/>
-            <a:ext cx="468000" cy="198000"/>
+            <a:off x="1152000" y="2210400"/>
+            <a:ext cx="540000" cy="198000"/>
           </a:xfrm>
           <a:prstGeom prst="rect">
             <a:avLst/>
@@ -8640,7 +8640,7 @@
         </p:nvSpPr>
         <p:spPr>
           <a:xfrm>
-            <a:off x="1655999" y="2210400"/>
+            <a:off x="1692000" y="2210400"/>
             <a:ext cx="540000" cy="198000"/>
           </a:xfrm>
           <a:prstGeom prst="rect">
@@ -8674,7 +8674,7 @@
         </p:nvSpPr>
         <p:spPr>
           <a:xfrm>
-            <a:off x="2196000" y="2210400"/>
+            <a:off x="2232000" y="2210400"/>
             <a:ext cx="540000" cy="198000"/>
           </a:xfrm>
           <a:prstGeom prst="rect">
@@ -9239,7 +9239,7 @@
         <p:spPr>
           <a:xfrm>
             <a:off x="3294000" y="1620000"/>
-            <a:ext cx="720000" cy="198000"/>
+            <a:ext cx="684000" cy="198000"/>
           </a:xfrm>
           <a:prstGeom prst="rect">
             <a:avLst/>
@@ -9272,8 +9272,8 @@
         </p:nvSpPr>
         <p:spPr>
           <a:xfrm>
-            <a:off x="4014000" y="1620000"/>
-            <a:ext cx="468000" cy="198000"/>
+            <a:off x="3978000" y="1620000"/>
+            <a:ext cx="540000" cy="198000"/>
           </a:xfrm>
           <a:prstGeom prst="rect">
             <a:avLst/>
@@ -9306,7 +9306,7 @@
         </p:nvSpPr>
         <p:spPr>
           <a:xfrm>
-            <a:off x="4482000" y="1620000"/>
+            <a:off x="4518000" y="1620000"/>
             <a:ext cx="540000" cy="198000"/>
           </a:xfrm>
           <a:prstGeom prst="rect">
@@ -9340,7 +9340,7 @@
         </p:nvSpPr>
         <p:spPr>
           <a:xfrm>
-            <a:off x="5022000" y="1620000"/>
+            <a:off x="5058000" y="1620000"/>
             <a:ext cx="540000" cy="198000"/>
           </a:xfrm>
           <a:prstGeom prst="rect">
@@ -9418,7 +9418,7 @@
         <p:spPr>
           <a:xfrm>
             <a:off x="3294000" y="1915200"/>
-            <a:ext cx="720000" cy="198000"/>
+            <a:ext cx="684000" cy="198000"/>
           </a:xfrm>
           <a:prstGeom prst="rect">
             <a:avLst/>
@@ -9451,8 +9451,8 @@
         </p:nvSpPr>
         <p:spPr>
           <a:xfrm>
-            <a:off x="4014000" y="1915200"/>
-            <a:ext cx="468000" cy="198000"/>
+            <a:off x="3978000" y="1915200"/>
+            <a:ext cx="540000" cy="198000"/>
           </a:xfrm>
           <a:prstGeom prst="rect">
             <a:avLst/>
@@ -9485,7 +9485,7 @@
         </p:nvSpPr>
         <p:spPr>
           <a:xfrm>
-            <a:off x="4482000" y="1915200"/>
+            <a:off x="4518000" y="1915200"/>
             <a:ext cx="540000" cy="198000"/>
           </a:xfrm>
           <a:prstGeom prst="rect">
@@ -9519,7 +9519,7 @@
         </p:nvSpPr>
         <p:spPr>
           <a:xfrm>
-            <a:off x="5022000" y="1915200"/>
+            <a:off x="5058000" y="1915200"/>
             <a:ext cx="540000" cy="198000"/>
           </a:xfrm>
           <a:prstGeom prst="rect">
@@ -9597,7 +9597,7 @@
         <p:spPr>
           <a:xfrm>
             <a:off x="3294000" y="2210400"/>
-            <a:ext cx="720000" cy="198000"/>
+            <a:ext cx="684000" cy="198000"/>
           </a:xfrm>
           <a:prstGeom prst="rect">
             <a:avLst/>
@@ -9630,8 +9630,8 @@
         </p:nvSpPr>
         <p:spPr>
           <a:xfrm>
-            <a:off x="4014000" y="2210400"/>
-            <a:ext cx="468000" cy="198000"/>
+            <a:off x="3978000" y="2210400"/>
+            <a:ext cx="540000" cy="198000"/>
           </a:xfrm>
           <a:prstGeom prst="rect">
             <a:avLst/>
@@ -9664,7 +9664,7 @@
         </p:nvSpPr>
         <p:spPr>
           <a:xfrm>
-            <a:off x="4482000" y="2210400"/>
+            <a:off x="4518000" y="2210400"/>
             <a:ext cx="540000" cy="198000"/>
           </a:xfrm>
           <a:prstGeom prst="rect">
@@ -9698,7 +9698,7 @@
         </p:nvSpPr>
         <p:spPr>
           <a:xfrm>
-            <a:off x="5022000" y="2210400"/>
+            <a:off x="5058000" y="2210400"/>
             <a:ext cx="540000" cy="198000"/>
           </a:xfrm>
           <a:prstGeom prst="rect">
@@ -10263,7 +10263,7 @@
         <p:spPr>
           <a:xfrm>
             <a:off x="6119999" y="1620000"/>
-            <a:ext cx="720000" cy="198000"/>
+            <a:ext cx="684000" cy="198000"/>
           </a:xfrm>
           <a:prstGeom prst="rect">
             <a:avLst/>
@@ -10296,8 +10296,8 @@
         </p:nvSpPr>
         <p:spPr>
           <a:xfrm>
-            <a:off x="6839999" y="1620000"/>
-            <a:ext cx="468000" cy="198000"/>
+            <a:off x="6803999" y="1620000"/>
+            <a:ext cx="540000" cy="198000"/>
           </a:xfrm>
           <a:prstGeom prst="rect">
             <a:avLst/>
@@ -10330,7 +10330,7 @@
         </p:nvSpPr>
         <p:spPr>
           <a:xfrm>
-            <a:off x="7307999" y="1620000"/>
+            <a:off x="7343999" y="1620000"/>
             <a:ext cx="540000" cy="198000"/>
           </a:xfrm>
           <a:prstGeom prst="rect">
@@ -10364,7 +10364,7 @@
         </p:nvSpPr>
         <p:spPr>
           <a:xfrm>
-            <a:off x="7847999" y="1620000"/>
+            <a:off x="7883999" y="1620000"/>
             <a:ext cx="540000" cy="198000"/>
           </a:xfrm>
           <a:prstGeom prst="rect">
@@ -10442,7 +10442,7 @@
         <p:spPr>
           <a:xfrm>
             <a:off x="6119999" y="1915200"/>
-            <a:ext cx="720000" cy="198000"/>
+            <a:ext cx="684000" cy="198000"/>
           </a:xfrm>
           <a:prstGeom prst="rect">
             <a:avLst/>
@@ -10475,8 +10475,8 @@
         </p:nvSpPr>
         <p:spPr>
           <a:xfrm>
-            <a:off x="6839999" y="1915200"/>
-            <a:ext cx="468000" cy="198000"/>
+            <a:off x="6803999" y="1915200"/>
+            <a:ext cx="540000" cy="198000"/>
           </a:xfrm>
           <a:prstGeom prst="rect">
             <a:avLst/>
@@ -10509,7 +10509,7 @@
         </p:nvSpPr>
         <p:spPr>
           <a:xfrm>
-            <a:off x="7307999" y="1915200"/>
+            <a:off x="7343999" y="1915200"/>
             <a:ext cx="540000" cy="198000"/>
           </a:xfrm>
           <a:prstGeom prst="rect">
@@ -10543,7 +10543,7 @@
         </p:nvSpPr>
         <p:spPr>
           <a:xfrm>
-            <a:off x="7847999" y="1915200"/>
+            <a:off x="7883999" y="1915200"/>
             <a:ext cx="540000" cy="198000"/>
           </a:xfrm>
           <a:prstGeom prst="rect">
@@ -10621,7 +10621,7 @@
         <p:spPr>
           <a:xfrm>
             <a:off x="6119999" y="2210400"/>
-            <a:ext cx="720000" cy="198000"/>
+            <a:ext cx="684000" cy="198000"/>
           </a:xfrm>
           <a:prstGeom prst="rect">
             <a:avLst/>
@@ -10654,8 +10654,8 @@
         </p:nvSpPr>
         <p:spPr>
           <a:xfrm>
-            <a:off x="6839999" y="2210400"/>
-            <a:ext cx="468000" cy="198000"/>
+            <a:off x="6803999" y="2210400"/>
+            <a:ext cx="540000" cy="198000"/>
           </a:xfrm>
           <a:prstGeom prst="rect">
             <a:avLst/>
@@ -10688,7 +10688,7 @@
         </p:nvSpPr>
         <p:spPr>
           <a:xfrm>
-            <a:off x="7307999" y="2210400"/>
+            <a:off x="7343999" y="2210400"/>
             <a:ext cx="540000" cy="198000"/>
           </a:xfrm>
           <a:prstGeom prst="rect">
@@ -10722,7 +10722,7 @@
         </p:nvSpPr>
         <p:spPr>
           <a:xfrm>
-            <a:off x="7847999" y="2210400"/>
+            <a:off x="7883999" y="2210400"/>
             <a:ext cx="540000" cy="198000"/>
           </a:xfrm>
           <a:prstGeom prst="rect">

</xml_diff>